<commit_message>
Sửa tên GVHD thành Th.S Nguyễn Văn Danh trên báo cáo, slide và tài liệu
</commit_message>
<xml_diff>
--- a/slides/Slide_PhanManhHonHop.pptx
+++ b/slides/Slide_PhanManhHonHop.pptx
@@ -123,13 +123,13 @@
   <p:extLst>
     <p:ext uri="{521415D9-36F7-43E2-AB2F-B90AF26B5E84}">
       <p14:sectionLst xmlns:p14="http://schemas.microsoft.com/office/powerpoint/2010/main">
-        <p14:section name="Mở đầu" id="{4ec31be4-cd1d-cd0f-6ae1-18e451ca8481}">
+        <p14:section name="Mở đầu" id="{e5811f76-d467-e1da-27bd-dae99890d697}">
           <p14:sldIdLst>
             <p14:sldId id="256"/>
             <p14:sldId id="257"/>
           </p14:sldIdLst>
         </p14:section>
-        <p14:section name="Lý thuyết" id="{9999f27a-c14f-f948-0139-90143245ee6f}">
+        <p14:section name="Lý thuyết" id="{5737075a-a477-3137-9b09-b55e0ce2b750}">
           <p14:sldIdLst>
             <p14:sldId id="258"/>
             <p14:sldId id="259"/>
@@ -140,7 +140,7 @@
             <p14:sldId id="264"/>
           </p14:sldIdLst>
         </p14:section>
-        <p14:section name="Ứng dụng" id="{37382564-6a50-5fd6-b568-3df12d65805b}">
+        <p14:section name="Ứng dụng" id="{343d4c69-c6a0-06b2-9ee5-13ea8e7b4046}">
           <p14:sldIdLst>
             <p14:sldId id="265"/>
             <p14:sldId id="266"/>
@@ -150,7 +150,7 @@
             <p14:sldId id="270"/>
           </p14:sldIdLst>
         </p14:section>
-        <p14:section name="Kết luận" id="{97881258-5d3e-5445-4bf2-15e790bc04ff}">
+        <p14:section name="Kết luận" id="{cfca65f9-1b64-5d4c-ba65-618868929dbf}">
           <p14:sldIdLst>
             <p14:sldId id="271"/>
             <p14:sldId id="272"/>
@@ -2822,7 +2822,7 @@
                   <a:schemeClr val="bg1"/>
                 </a:solidFill>
               </a:rPr>
-              <a:t>Nguyễn Văn Danh</a:t>
+              <a:t>Th.S Nguyễn Văn Danh</a:t>
             </a:r>
             <a:endParaRPr lang="en-US" sz="1600" dirty="0"/>
           </a:p>

</xml_diff>

<commit_message>
Đổi cách viết học vị GVHD sang ThS. Nguyễn Văn Danh
</commit_message>
<xml_diff>
--- a/slides/Slide_PhanManhHonHop.pptx
+++ b/slides/Slide_PhanManhHonHop.pptx
@@ -123,13 +123,13 @@
   <p:extLst>
     <p:ext uri="{521415D9-36F7-43E2-AB2F-B90AF26B5E84}">
       <p14:sectionLst xmlns:p14="http://schemas.microsoft.com/office/powerpoint/2010/main">
-        <p14:section name="Mở đầu" id="{e5811f76-d467-e1da-27bd-dae99890d697}">
+        <p14:section name="Mở đầu" id="{b3561aca-7621-cf83-94ab-b061b4f408da}">
           <p14:sldIdLst>
             <p14:sldId id="256"/>
             <p14:sldId id="257"/>
           </p14:sldIdLst>
         </p14:section>
-        <p14:section name="Lý thuyết" id="{5737075a-a477-3137-9b09-b55e0ce2b750}">
+        <p14:section name="Lý thuyết" id="{7daed965-07d7-3927-0b22-779847d79281}">
           <p14:sldIdLst>
             <p14:sldId id="258"/>
             <p14:sldId id="259"/>
@@ -140,7 +140,7 @@
             <p14:sldId id="264"/>
           </p14:sldIdLst>
         </p14:section>
-        <p14:section name="Ứng dụng" id="{343d4c69-c6a0-06b2-9ee5-13ea8e7b4046}">
+        <p14:section name="Ứng dụng" id="{b036f6d2-703b-818b-6fb4-896abe5a03bf}">
           <p14:sldIdLst>
             <p14:sldId id="265"/>
             <p14:sldId id="266"/>
@@ -150,7 +150,7 @@
             <p14:sldId id="270"/>
           </p14:sldIdLst>
         </p14:section>
-        <p14:section name="Kết luận" id="{cfca65f9-1b64-5d4c-ba65-618868929dbf}">
+        <p14:section name="Kết luận" id="{e41da85a-21ae-5d62-ca07-74e4adfe810a}">
           <p14:sldIdLst>
             <p14:sldId id="271"/>
             <p14:sldId id="272"/>
@@ -2822,7 +2822,7 @@
                   <a:schemeClr val="bg1"/>
                 </a:solidFill>
               </a:rPr>
-              <a:t>Th.S Nguyễn Văn Danh</a:t>
+              <a:t>ThS. Nguyễn Văn Danh</a:t>
             </a:r>
             <a:endParaRPr lang="en-US" sz="1600" dirty="0"/>
           </a:p>

</xml_diff>

<commit_message>
Sua hoc vi GVHD
</commit_message>
<xml_diff>
--- a/slides/Slide_PhanManhHonHop.pptx
+++ b/slides/Slide_PhanManhHonHop.pptx
@@ -123,13 +123,13 @@
   <p:extLst>
     <p:ext uri="{521415D9-36F7-43E2-AB2F-B90AF26B5E84}">
       <p14:sectionLst xmlns:p14="http://schemas.microsoft.com/office/powerpoint/2010/main">
-        <p14:section name="Mở đầu" id="{e5811f76-d467-e1da-27bd-dae99890d697}">
+        <p14:section name="Mở đầu" id="{b3561aca-7621-cf83-94ab-b061b4f408da}">
           <p14:sldIdLst>
             <p14:sldId id="256"/>
             <p14:sldId id="257"/>
           </p14:sldIdLst>
         </p14:section>
-        <p14:section name="Lý thuyết" id="{5737075a-a477-3137-9b09-b55e0ce2b750}">
+        <p14:section name="Lý thuyết" id="{7daed965-07d7-3927-0b22-779847d79281}">
           <p14:sldIdLst>
             <p14:sldId id="258"/>
             <p14:sldId id="259"/>
@@ -140,7 +140,7 @@
             <p14:sldId id="264"/>
           </p14:sldIdLst>
         </p14:section>
-        <p14:section name="Ứng dụng" id="{343d4c69-c6a0-06b2-9ee5-13ea8e7b4046}">
+        <p14:section name="Ứng dụng" id="{b036f6d2-703b-818b-6fb4-896abe5a03bf}">
           <p14:sldIdLst>
             <p14:sldId id="265"/>
             <p14:sldId id="266"/>
@@ -150,7 +150,7 @@
             <p14:sldId id="270"/>
           </p14:sldIdLst>
         </p14:section>
-        <p14:section name="Kết luận" id="{cfca65f9-1b64-5d4c-ba65-618868929dbf}">
+        <p14:section name="Kết luận" id="{e41da85a-21ae-5d62-ca07-74e4adfe810a}">
           <p14:sldIdLst>
             <p14:sldId id="271"/>
             <p14:sldId id="272"/>
@@ -2822,7 +2822,7 @@
                   <a:schemeClr val="bg1"/>
                 </a:solidFill>
               </a:rPr>
-              <a:t>Th.S Nguyễn Văn Danh</a:t>
+              <a:t>ThS. Nguyễn Văn Danh</a:t>
             </a:r>
             <a:endParaRPr lang="en-US" sz="1600" dirty="0"/>
           </a:p>

</xml_diff>

<commit_message>
Chay demo, them anh SSMS
</commit_message>
<xml_diff>
--- a/slides/Slide_PhanManhHonHop.pptx
+++ b/slides/Slide_PhanManhHonHop.pptx
@@ -123,13 +123,13 @@
   <p:extLst>
     <p:ext uri="{521415D9-36F7-43E2-AB2F-B90AF26B5E84}">
       <p14:sectionLst xmlns:p14="http://schemas.microsoft.com/office/powerpoint/2010/main">
-        <p14:section name="Mở đầu" id="{b3561aca-7621-cf83-94ab-b061b4f408da}">
+        <p14:section name="Mở đầu" id="{3be2ea5d-9aeb-db3c-cbfe-cbdd0d9d1358}">
           <p14:sldIdLst>
             <p14:sldId id="256"/>
             <p14:sldId id="257"/>
           </p14:sldIdLst>
         </p14:section>
-        <p14:section name="Lý thuyết" id="{7daed965-07d7-3927-0b22-779847d79281}">
+        <p14:section name="Lý thuyết" id="{76baa6c2-8440-4db8-0525-46dd356de760}">
           <p14:sldIdLst>
             <p14:sldId id="258"/>
             <p14:sldId id="259"/>
@@ -140,7 +140,7 @@
             <p14:sldId id="264"/>
           </p14:sldIdLst>
         </p14:section>
-        <p14:section name="Ứng dụng" id="{b036f6d2-703b-818b-6fb4-896abe5a03bf}">
+        <p14:section name="Ứng dụng" id="{3f2d67a4-4a9b-28c0-8d5a-fadd2869ad16}">
           <p14:sldIdLst>
             <p14:sldId id="265"/>
             <p14:sldId id="266"/>
@@ -150,7 +150,7 @@
             <p14:sldId id="270"/>
           </p14:sldIdLst>
         </p14:section>
-        <p14:section name="Kết luận" id="{e41da85a-21ae-5d62-ca07-74e4adfe810a}">
+        <p14:section name="Kết luận" id="{770d07ee-6c13-54d0-1ed0-94a7b8e5b91b}">
           <p14:sldIdLst>
             <p14:sldId id="271"/>
             <p14:sldId id="272"/>
@@ -1106,7 +1106,7 @@
               <a:t>[Triết · 1:30]
 Nhóm cài đặt thiết kế này trên SQL Server. Mỗi site được mô phỏng bằng một database riêng: trụ sở, Hà Nội, Đà Nẵng và TP.HCM. Dữ liệu được phân mảnh từ một CSDL gốc, đúng theo các biểu thức đại số vừa trình bày.
 Ở trụ sở, nhóm tạo synonym trỏ tới các mảnh ở chi nhánh, rồi tạo view tái thiết dựa trên synonym đó. Người dùng chỉ cần truy vấn view khách hàng như một bảng bình thường, không cần biết dữ liệu nằm ở mảnh nào hay ở site nào.
-Để chứng minh phân mảnh đúng, nhóm viết các truy vấn tự kiểm tra ba quy tắc. Kết quả là cả 13 phép kiểm tra đều đạt. Nhóm cũng ghi điều kiện phân mảnh thành ràng buộc CHECK, nên mảnh Hà Nội không nhận khách của chi nhánh khác. Chi nhánh truy vấn cột lương sẽ bị báo lỗi, vì cột đó không tồn tại ở chi nhánh.
+Để chứng minh phân mảnh đúng, nhóm viết các truy vấn tự kiểm tra ba quy tắc. Kết quả là cả 14 phép kiểm tra đều đạt. Nhóm cũng ghi điều kiện phân mảnh thành ràng buộc CHECK, nên mảnh Hà Nội không nhận khách của chi nhánh khác. Chi nhánh truy vấn cột lương sẽ bị báo lỗi, vì cột đó không tồn tại ở chi nhánh.
 Cuối cùng là một giao dịch phân tán: chi nhánh lập đơn và trụ sở cập nhật công nợ. Nếu đơn vượt hạn mức, cả hai site cùng hủy, không có site nào bị ghi dở.</a:t>
             </a:r>
             <a:endParaRPr lang="en-US" dirty="0"/>
@@ -1289,7 +1289,7 @@
 Phần trình bày của nhóm em đến đây là kết thúc. Nhóm em cảm ơn thầy và các bạn đã lắng nghe, mong nhận được câu hỏi và góp ý.
 Đây là mô phỏng: mỗi database đóng vai một site, và ranh giới giữa các site là ranh giới database. Thiết kế phân mảnh và cấp phát không phụ thuộc hạ tầng. Ở trụ sở, view chỉ tham chiếu synonym, nên muốn chạy trên nhiều máy thì chỉ cần tạo Linked Server và cho synonym trỏ tới tên 4 phần `[MayKhac].QLDH_HN.dbo.KH_1_GD`; view và truy vấn giữ nguyên. *(Nếu làm được T4b thì mở ảnh chụp chạy trên 2 laptop.)*
 Khác nhau ở chỗ nút nào được chia tiếp. Với KhachHang, phần tài chính cũng cần tách theo miền để kế toán báo cáo theo miền, nên chia ngang trước rồi mới chia dọc từng mảnh (HV). Với NhanVien, phần nhân sự xử lý tập trung, không cần chia theo chi nhánh, nên chia dọc trước và chỉ chia ngang phần công việc (VH). Hơn nữa, NV_NS không có cột MaCN nên cũng không chia ngang trực tiếp theo chi nhánh được.
-Đầy đủ: tập vị từ MaCN = CN01/CN02/CN03 phủ hết miền giá trị (có ràng buộc CHECK), và hợp các nhóm cột bằng toàn bộ cột. Tái thiết: ghép theo khóa chính thì không mất và không thừa bộ. Rời nhau: các vị từ loại trừ nhau, và hai mảnh dọc chỉ dùng chung khóa. Demo kiểm tra cả ba quy tắc bằng EXCEPT và GROUP BY … HAVING, kết quả 13/13 đạt.
+Đầy đủ: tập vị từ MaCN = CN01/CN02/CN03 phủ hết miền giá trị (có ràng buộc CHECK), và hợp các nhóm cột bằng toàn bộ cột. Tái thiết: ghép theo khóa chính thì không mất và không thừa bộ. Rời nhau: các vị từ loại trừ nhau, và hai mảnh dọc chỉ dùng chung khóa. Demo kiểm tra cả ba quy tắc bằng EXCEPT và GROUP BY … HAVING, kết quả 14/14 đạt.
 Vì các mảnh ngang rời nhau nên không có bộ trùng để loại. UNION ALL cho cùng kết quả mà không tốn chi phí sắp xếp để khử trùng lặp.
 Phải chuyển bộ đó từ mảnh KH_1 sang KH_2, gồm cả phần GD ở site chi nhánh và phần TC ở trụ sở, kèm các đơn hàng dẫn xuất nếu muốn đơn đi theo khách. Thao tác này là một giao dịch phân tán. Ràng buộc CHECK bảo đảm không thể sửa MaCN tại chỗ mà để sai mảnh.
 Bảng nhỏ, mọi chi nhánh đều đọc khi lập đơn, và chỉ trụ sở cập nhật giá. Nhân bản giúp lập đơn không phải truy cập từ xa; đổi lại, mỗi lần đổi giá phải đồng bộ xuống 3 chi nhánh. Vì giá ít thay đổi nên chi phí đó chấp nhận được.
@@ -8544,7 +8544,7 @@
                   <a:schemeClr val="tx1"/>
                 </a:solidFill>
               </a:rPr>
-              <a:t>: 13/13 </a:t>
+              <a:t>: 14/14 </a:t>
             </a:r>
             <a:pPr indent="0" marL="0">
               <a:buNone/>
@@ -8786,58 +8786,44 @@
             <a:off x="6263640" y="1600200"/>
             <a:ext cx="2697480" cy="2103120"/>
           </a:xfrm>
-          <a:prstGeom prst="roundRect">
-            <a:avLst>
-              <a:gd name="adj" fmla="val 4348"/>
-            </a:avLst>
+          <a:prstGeom prst="rect">
+            <a:avLst/>
           </a:prstGeom>
           <a:solidFill>
             <a:schemeClr val="bg2"/>
           </a:solidFill>
-          <a:ln w="15875">
+          <a:ln w="9525">
             <a:solidFill>
               <a:srgbClr val="4B5563"/>
             </a:solidFill>
-            <a:prstDash val="dash"/>
+            <a:prstDash val="solid"/>
           </a:ln>
         </p:spPr>
       </p:sp>
-      <p:sp>
-        <p:nvSpPr>
-          <p:cNvPr id="21" name="Text 13"/>
-          <p:cNvSpPr txBox="1"/>
-          <p:nvPr/>
-        </p:nvSpPr>
-        <p:spPr>
-          <a:xfrm>
-            <a:off x="6400800" y="1600200"/>
-            <a:ext cx="2423160" cy="2103120"/>
-          </a:xfrm>
-          <a:prstGeom prst="rect">
-            <a:avLst/>
-          </a:prstGeom>
-          <a:noFill/>
-          <a:ln/>
-        </p:spPr>
-        <p:txBody>
-          <a:bodyPr wrap="square" lIns="0" tIns="0" rIns="0" bIns="0" rtlCol="0" anchor="ctr"/>
-          <a:lstStyle/>
-          <a:p>
-            <a:pPr algn="ctr" indent="0" marL="0">
-              <a:buNone/>
-            </a:pPr>
-            <a:r>
-              <a:rPr lang="en-US" sz="1200" dirty="0">
-                <a:solidFill>
-                  <a:schemeClr val="tx2"/>
-                </a:solidFill>
-              </a:rPr>
-              <a:t>Chèn ảnh: demo_01_object_explorer.png</a:t>
-            </a:r>
-            <a:endParaRPr lang="en-US" sz="1200" dirty="0"/>
-          </a:p>
-        </p:txBody>
-      </p:sp>
+      <p:pic>
+        <p:nvPicPr>
+          <p:cNvPr id="21" name="slide15_1_object_explorer" descr="D:\Projects\University\CSDLNC-PhanManhHonHop\assets\screenshots\slide15_1_object_explorer.png">    </p:cNvPr>
+          <p:cNvPicPr>
+            <a:picLocks noChangeAspect="1"/>
+          </p:cNvPicPr>
+          <p:nvPr/>
+        </p:nvPicPr>
+        <p:blipFill>
+          <a:blip r:embed="rId6"/>
+          <a:stretch>
+            <a:fillRect/>
+          </a:stretch>
+        </p:blipFill>
+        <p:spPr>
+          <a:xfrm>
+            <a:off x="6648450" y="1645920"/>
+            <a:ext cx="1927860" cy="2011680"/>
+          </a:xfrm>
+          <a:prstGeom prst="rect">
+            <a:avLst/>
+          </a:prstGeom>
+        </p:spPr>
+      </p:pic>
       <p:sp>
         <p:nvSpPr>
           <p:cNvPr id="22" name="khung-anh-demo"/>
@@ -8849,58 +8835,44 @@
             <a:off x="9125712" y="1600200"/>
             <a:ext cx="2697480" cy="2103120"/>
           </a:xfrm>
-          <a:prstGeom prst="roundRect">
-            <a:avLst>
-              <a:gd name="adj" fmla="val 4348"/>
-            </a:avLst>
+          <a:prstGeom prst="rect">
+            <a:avLst/>
           </a:prstGeom>
           <a:solidFill>
             <a:schemeClr val="bg2"/>
           </a:solidFill>
-          <a:ln w="15875">
+          <a:ln w="9525">
             <a:solidFill>
               <a:srgbClr val="4B5563"/>
             </a:solidFill>
-            <a:prstDash val="dash"/>
+            <a:prstDash val="solid"/>
           </a:ln>
         </p:spPr>
       </p:sp>
-      <p:sp>
-        <p:nvSpPr>
-          <p:cNvPr id="23" name="Text 15"/>
-          <p:cNvSpPr txBox="1"/>
-          <p:nvPr/>
-        </p:nvSpPr>
-        <p:spPr>
-          <a:xfrm>
-            <a:off x="9262872" y="1600200"/>
-            <a:ext cx="2423160" cy="2103120"/>
-          </a:xfrm>
-          <a:prstGeom prst="rect">
-            <a:avLst/>
-          </a:prstGeom>
-          <a:noFill/>
-          <a:ln/>
-        </p:spPr>
-        <p:txBody>
-          <a:bodyPr wrap="square" lIns="0" tIns="0" rIns="0" bIns="0" rtlCol="0" anchor="ctr"/>
-          <a:lstStyle/>
-          <a:p>
-            <a:pPr algn="ctr" indent="0" marL="0">
-              <a:buNone/>
-            </a:pPr>
-            <a:r>
-              <a:rPr lang="en-US" sz="1200" dirty="0">
-                <a:solidFill>
-                  <a:schemeClr val="tx2"/>
-                </a:solidFill>
-              </a:rPr>
-              <a:t>Chèn ảnh: demo_05_kiem_tra_dung_dan.png</a:t>
-            </a:r>
-            <a:endParaRPr lang="en-US" sz="1200" dirty="0"/>
-          </a:p>
-        </p:txBody>
-      </p:sp>
+      <p:pic>
+        <p:nvPicPr>
+          <p:cNvPr id="23" name="slide15_2_kiem_tra" descr="D:\Projects\University\CSDLNC-PhanManhHonHop\assets\screenshots\slide15_2_kiem_tra.png">    </p:cNvPr>
+          <p:cNvPicPr>
+            <a:picLocks noChangeAspect="1"/>
+          </p:cNvPicPr>
+          <p:nvPr/>
+        </p:nvPicPr>
+        <p:blipFill>
+          <a:blip r:embed="rId7"/>
+          <a:stretch>
+            <a:fillRect/>
+          </a:stretch>
+        </p:blipFill>
+        <p:spPr>
+          <a:xfrm>
+            <a:off x="9171432" y="2071287"/>
+            <a:ext cx="2606040" cy="1160946"/>
+          </a:xfrm>
+          <a:prstGeom prst="rect">
+            <a:avLst/>
+          </a:prstGeom>
+        </p:spPr>
+      </p:pic>
       <p:sp>
         <p:nvSpPr>
           <p:cNvPr id="24" name="khung-anh-demo"/>
@@ -8912,58 +8884,44 @@
             <a:off x="6263640" y="3886200"/>
             <a:ext cx="2697480" cy="2103120"/>
           </a:xfrm>
-          <a:prstGeom prst="roundRect">
-            <a:avLst>
-              <a:gd name="adj" fmla="val 4348"/>
-            </a:avLst>
+          <a:prstGeom prst="rect">
+            <a:avLst/>
           </a:prstGeom>
           <a:solidFill>
             <a:schemeClr val="bg2"/>
           </a:solidFill>
-          <a:ln w="15875">
+          <a:ln w="9525">
             <a:solidFill>
               <a:srgbClr val="4B5563"/>
             </a:solidFill>
-            <a:prstDash val="dash"/>
+            <a:prstDash val="solid"/>
           </a:ln>
         </p:spPr>
       </p:sp>
-      <p:sp>
-        <p:nvSpPr>
-          <p:cNvPr id="25" name="Text 17"/>
-          <p:cNvSpPr txBox="1"/>
-          <p:nvPr/>
-        </p:nvSpPr>
-        <p:spPr>
-          <a:xfrm>
-            <a:off x="6400800" y="3886200"/>
-            <a:ext cx="2423160" cy="2103120"/>
-          </a:xfrm>
-          <a:prstGeom prst="rect">
-            <a:avLst/>
-          </a:prstGeom>
-          <a:noFill/>
-          <a:ln/>
-        </p:spPr>
-        <p:txBody>
-          <a:bodyPr wrap="square" lIns="0" tIns="0" rIns="0" bIns="0" rtlCol="0" anchor="ctr"/>
-          <a:lstStyle/>
-          <a:p>
-            <a:pPr algn="ctr" indent="0" marL="0">
-              <a:buNone/>
-            </a:pPr>
-            <a:r>
-              <a:rPr lang="en-US" sz="1200" dirty="0">
-                <a:solidFill>
-                  <a:schemeClr val="tx2"/>
-                </a:solidFill>
-              </a:rPr>
-              <a:t>Chèn ảnh: demo_07_truy_van_toan_cuc.png</a:t>
-            </a:r>
-            <a:endParaRPr lang="en-US" sz="1200" dirty="0"/>
-          </a:p>
-        </p:txBody>
-      </p:sp>
+      <p:pic>
+        <p:nvPicPr>
+          <p:cNvPr id="25" name="slide15_3_toan_cuc" descr="D:\Projects\University\CSDLNC-PhanManhHonHop\assets\screenshots\slide15_3_toan_cuc.png">    </p:cNvPr>
+          <p:cNvPicPr>
+            <a:picLocks noChangeAspect="1"/>
+          </p:cNvPicPr>
+          <p:nvPr/>
+        </p:nvPicPr>
+        <p:blipFill>
+          <a:blip r:embed="rId8"/>
+          <a:stretch>
+            <a:fillRect/>
+          </a:stretch>
+        </p:blipFill>
+        <p:spPr>
+          <a:xfrm>
+            <a:off x="6309360" y="4042724"/>
+            <a:ext cx="2606040" cy="1790071"/>
+          </a:xfrm>
+          <a:prstGeom prst="rect">
+            <a:avLst/>
+          </a:prstGeom>
+        </p:spPr>
+      </p:pic>
       <p:sp>
         <p:nvSpPr>
           <p:cNvPr id="26" name="khung-anh-demo"/>
@@ -8975,58 +8933,44 @@
             <a:off x="9125712" y="3886200"/>
             <a:ext cx="2697480" cy="2103120"/>
           </a:xfrm>
-          <a:prstGeom prst="roundRect">
-            <a:avLst>
-              <a:gd name="adj" fmla="val 4348"/>
-            </a:avLst>
+          <a:prstGeom prst="rect">
+            <a:avLst/>
           </a:prstGeom>
           <a:solidFill>
             <a:schemeClr val="bg2"/>
           </a:solidFill>
-          <a:ln w="15875">
+          <a:ln w="9525">
             <a:solidFill>
               <a:srgbClr val="4B5563"/>
             </a:solidFill>
-            <a:prstDash val="dash"/>
+            <a:prstDash val="solid"/>
           </a:ln>
         </p:spPr>
       </p:sp>
-      <p:sp>
-        <p:nvSpPr>
-          <p:cNvPr id="27" name="Text 19"/>
-          <p:cNvSpPr txBox="1"/>
-          <p:nvPr/>
-        </p:nvSpPr>
-        <p:spPr>
-          <a:xfrm>
-            <a:off x="9262872" y="3886200"/>
-            <a:ext cx="2423160" cy="2103120"/>
-          </a:xfrm>
-          <a:prstGeom prst="rect">
-            <a:avLst/>
-          </a:prstGeom>
-          <a:noFill/>
-          <a:ln/>
-        </p:spPr>
-        <p:txBody>
-          <a:bodyPr wrap="square" lIns="0" tIns="0" rIns="0" bIns="0" rtlCol="0" anchor="ctr"/>
-          <a:lstStyle/>
-          <a:p>
-            <a:pPr algn="ctr" indent="0" marL="0">
-              <a:buNone/>
-            </a:pPr>
-            <a:r>
-              <a:rPr lang="en-US" sz="1200" dirty="0">
-                <a:solidFill>
-                  <a:schemeClr val="tx2"/>
-                </a:solidFill>
-              </a:rPr>
-              <a:t>Chèn ảnh: demo_08_giao_dich.png</a:t>
-            </a:r>
-            <a:endParaRPr lang="en-US" sz="1200" dirty="0"/>
-          </a:p>
-        </p:txBody>
-      </p:sp>
+      <p:pic>
+        <p:nvPicPr>
+          <p:cNvPr id="27" name="slide15_4_giao_dich" descr="D:\Projects\University\CSDLNC-PhanManhHonHop\assets\screenshots\slide15_4_giao_dich.png">    </p:cNvPr>
+          <p:cNvPicPr>
+            <a:picLocks noChangeAspect="1"/>
+          </p:cNvPicPr>
+          <p:nvPr/>
+        </p:nvPicPr>
+        <p:blipFill>
+          <a:blip r:embed="rId9"/>
+          <a:stretch>
+            <a:fillRect/>
+          </a:stretch>
+        </p:blipFill>
+        <p:spPr>
+          <a:xfrm>
+            <a:off x="9449836" y="3931920"/>
+            <a:ext cx="2049231" cy="2011680"/>
+          </a:xfrm>
+          <a:prstGeom prst="rect">
+            <a:avLst/>
+          </a:prstGeom>
+        </p:spPr>
+      </p:pic>
       <p:sp>
         <p:nvSpPr>
           <p:cNvPr id="25" name="Slide Number Placeholder 0"/>

</xml_diff>

<commit_message>
Them ban rut gon, logo, ten lop
</commit_message>
<xml_diff>
--- a/slides/Slide_PhanManhHonHop.pptx
+++ b/slides/Slide_PhanManhHonHop.pptx
@@ -123,13 +123,13 @@
   <p:extLst>
     <p:ext uri="{521415D9-36F7-43E2-AB2F-B90AF26B5E84}">
       <p14:sectionLst xmlns:p14="http://schemas.microsoft.com/office/powerpoint/2010/main">
-        <p14:section name="Mở đầu" id="{3be2ea5d-9aeb-db3c-cbfe-cbdd0d9d1358}">
+        <p14:section name="Mở đầu" id="{73d13e12-7275-0363-23a4-255d50b85b95}">
           <p14:sldIdLst>
             <p14:sldId id="256"/>
             <p14:sldId id="257"/>
           </p14:sldIdLst>
         </p14:section>
-        <p14:section name="Lý thuyết" id="{76baa6c2-8440-4db8-0525-46dd356de760}">
+        <p14:section name="Lý thuyết" id="{2fbe44f8-e82c-6f22-0f4f-632316d98cde}">
           <p14:sldIdLst>
             <p14:sldId id="258"/>
             <p14:sldId id="259"/>
@@ -140,7 +140,7 @@
             <p14:sldId id="264"/>
           </p14:sldIdLst>
         </p14:section>
-        <p14:section name="Ứng dụng" id="{3f2d67a4-4a9b-28c0-8d5a-fadd2869ad16}">
+        <p14:section name="Ứng dụng" id="{00b678d1-160b-e8b6-9934-6f0d7b16f754}">
           <p14:sldIdLst>
             <p14:sldId id="265"/>
             <p14:sldId id="266"/>
@@ -150,7 +150,7 @@
             <p14:sldId id="270"/>
           </p14:sldIdLst>
         </p14:section>
-        <p14:section name="Kết luận" id="{770d07ee-6c13-54d0-1ed0-94a7b8e5b91b}">
+        <p14:section name="Kết luận" id="{cd7a2241-79b7-cefa-daa0-6a213ba33a64}">
           <p14:sldIdLst>
             <p14:sldId id="271"/>
             <p14:sldId id="272"/>
@@ -2667,7 +2667,7 @@
         <p:spPr>
           <a:xfrm>
             <a:off x="640080" y="548640"/>
-            <a:ext cx="8229600" cy="320040"/>
+            <a:ext cx="7680960" cy="320040"/>
           </a:xfrm>
           <a:prstGeom prst="rect">
             <a:avLst/>
@@ -2696,7 +2696,58 @@
       </p:sp>
       <p:sp>
         <p:nvSpPr>
-          <p:cNvPr id="4" name="Text 1"/>
+          <p:cNvPr id="4" name="nen-logo"/>
+          <p:cNvSpPr/>
+          <p:nvPr/>
+        </p:nvSpPr>
+        <p:spPr>
+          <a:xfrm>
+            <a:off x="8991295" y="274320"/>
+            <a:ext cx="2651760" cy="865708"/>
+          </a:xfrm>
+          <a:prstGeom prst="roundRect">
+            <a:avLst>
+              <a:gd name="adj" fmla="val 12675"/>
+            </a:avLst>
+          </a:prstGeom>
+          <a:solidFill>
+            <a:schemeClr val="bg1"/>
+          </a:solidFill>
+          <a:ln w="12700">
+            <a:solidFill>
+              <a:schemeClr val="bg1"/>
+            </a:solidFill>
+            <a:prstDash val="solid"/>
+          </a:ln>
+        </p:spPr>
+      </p:sp>
+      <p:pic>
+        <p:nvPicPr>
+          <p:cNvPr id="5" name="logo-hutech" descr="D:\Projects\University\CSDLNC-PhanManhHonHop\assets\logo_hutech.png">    </p:cNvPr>
+          <p:cNvPicPr>
+            <a:picLocks noChangeAspect="1"/>
+          </p:cNvPicPr>
+          <p:nvPr/>
+        </p:nvPicPr>
+        <p:blipFill>
+          <a:blip r:embed="rId1"/>
+          <a:stretch>
+            <a:fillRect/>
+          </a:stretch>
+        </p:blipFill>
+        <p:spPr>
+          <a:xfrm>
+            <a:off x="9128455" y="411480"/>
+            <a:ext cx="2377440" cy="591388"/>
+          </a:xfrm>
+          <a:prstGeom prst="rect">
+            <a:avLst/>
+          </a:prstGeom>
+        </p:spPr>
+      </p:pic>
+      <p:sp>
+        <p:nvSpPr>
+          <p:cNvPr id="6" name="Text 2"/>
           <p:cNvSpPr txBox="1"/>
           <p:nvPr/>
         </p:nvSpPr>
@@ -2732,7 +2783,7 @@
       </p:sp>
       <p:sp>
         <p:nvSpPr>
-          <p:cNvPr id="5" name="Text 2"/>
+          <p:cNvPr id="7" name="Text 3"/>
           <p:cNvSpPr txBox="1"/>
           <p:nvPr/>
         </p:nvSpPr>
@@ -2774,7 +2825,7 @@
       </p:sp>
       <p:sp>
         <p:nvSpPr>
-          <p:cNvPr id="6" name="Text 3"/>
+          <p:cNvPr id="8" name="Text 4"/>
           <p:cNvSpPr txBox="1"/>
           <p:nvPr/>
         </p:nvSpPr>
@@ -2830,7 +2881,7 @@
       </p:sp>
       <p:sp>
         <p:nvSpPr>
-          <p:cNvPr id="7" name="Text 4"/>
+          <p:cNvPr id="9" name="Text 5"/>
           <p:cNvSpPr txBox="1"/>
           <p:nvPr/>
         </p:nvSpPr>
@@ -2861,7 +2912,7 @@
                   <a:srgbClr val="D1D5DB"/>
                 </a:solidFill>
               </a:rPr>
-              <a:t>Nhóm thực hiện</a:t>
+              <a:t>Nhóm thực hiện · Lớp 23DTHE3</a:t>
             </a:r>
             <a:endParaRPr lang="en-US" sz="1600" dirty="0"/>
           </a:p>
@@ -2903,7 +2954,7 @@
       </p:sp>
       <p:sp>
         <p:nvSpPr>
-          <p:cNvPr id="8" name="Text 5"/>
+          <p:cNvPr id="10" name="Text 6"/>
           <p:cNvSpPr txBox="1"/>
           <p:nvPr/>
         </p:nvSpPr>
@@ -2939,7 +2990,7 @@
       </p:sp>
       <p:sp>
         <p:nvSpPr>
-          <p:cNvPr id="9" name="Text 6"/>
+          <p:cNvPr id="11" name="Text 7"/>
           <p:cNvSpPr txBox="1"/>
           <p:nvPr/>
         </p:nvSpPr>
@@ -2975,7 +3026,7 @@
       </p:sp>
       <p:sp>
         <p:nvSpPr>
-          <p:cNvPr id="10" name="o-manh"/>
+          <p:cNvPr id="12" name="o-manh"/>
           <p:cNvSpPr/>
           <p:nvPr/>
         </p:nvSpPr>
@@ -3002,7 +3053,7 @@
       </p:sp>
       <p:sp>
         <p:nvSpPr>
-          <p:cNvPr id="11" name="Text 8"/>
+          <p:cNvPr id="13" name="Text 9"/>
           <p:cNvSpPr txBox="1"/>
           <p:nvPr/>
         </p:nvSpPr>
@@ -3038,7 +3089,7 @@
       </p:sp>
       <p:sp>
         <p:nvSpPr>
-          <p:cNvPr id="12" name="o-manh"/>
+          <p:cNvPr id="14" name="o-manh"/>
           <p:cNvSpPr/>
           <p:nvPr/>
         </p:nvSpPr>
@@ -3065,7 +3116,7 @@
       </p:sp>
       <p:sp>
         <p:nvSpPr>
-          <p:cNvPr id="13" name="Text 10"/>
+          <p:cNvPr id="15" name="Text 11"/>
           <p:cNvSpPr txBox="1"/>
           <p:nvPr/>
         </p:nvSpPr>
@@ -3101,7 +3152,7 @@
       </p:sp>
       <p:sp>
         <p:nvSpPr>
-          <p:cNvPr id="14" name="o-manh"/>
+          <p:cNvPr id="16" name="o-manh"/>
           <p:cNvSpPr/>
           <p:nvPr/>
         </p:nvSpPr>
@@ -3128,7 +3179,7 @@
       </p:sp>
       <p:sp>
         <p:nvSpPr>
-          <p:cNvPr id="15" name="Text 12"/>
+          <p:cNvPr id="17" name="Text 13"/>
           <p:cNvSpPr txBox="1"/>
           <p:nvPr/>
         </p:nvSpPr>
@@ -3164,7 +3215,7 @@
       </p:sp>
       <p:sp>
         <p:nvSpPr>
-          <p:cNvPr id="16" name="o-manh"/>
+          <p:cNvPr id="18" name="o-manh"/>
           <p:cNvSpPr/>
           <p:nvPr/>
         </p:nvSpPr>
@@ -3191,7 +3242,7 @@
       </p:sp>
       <p:sp>
         <p:nvSpPr>
-          <p:cNvPr id="17" name="Text 14"/>
+          <p:cNvPr id="19" name="Text 15"/>
           <p:cNvSpPr txBox="1"/>
           <p:nvPr/>
         </p:nvSpPr>
@@ -3227,7 +3278,7 @@
       </p:sp>
       <p:sp>
         <p:nvSpPr>
-          <p:cNvPr id="18" name="o-manh"/>
+          <p:cNvPr id="20" name="o-manh"/>
           <p:cNvSpPr/>
           <p:nvPr/>
         </p:nvSpPr>
@@ -3254,7 +3305,7 @@
       </p:sp>
       <p:sp>
         <p:nvSpPr>
-          <p:cNvPr id="19" name="Text 16"/>
+          <p:cNvPr id="21" name="Text 17"/>
           <p:cNvSpPr txBox="1"/>
           <p:nvPr/>
         </p:nvSpPr>
@@ -3290,7 +3341,7 @@
       </p:sp>
       <p:sp>
         <p:nvSpPr>
-          <p:cNvPr id="20" name="o-manh"/>
+          <p:cNvPr id="22" name="o-manh"/>
           <p:cNvSpPr/>
           <p:nvPr/>
         </p:nvSpPr>
@@ -3317,7 +3368,7 @@
       </p:sp>
       <p:sp>
         <p:nvSpPr>
-          <p:cNvPr id="21" name="Text 18"/>
+          <p:cNvPr id="23" name="Text 19"/>
           <p:cNvSpPr txBox="1"/>
           <p:nvPr/>
         </p:nvSpPr>

</xml_diff>